<commit_message>
Mecanico: los cuatro pptx, regenerados desde sus generadores
Sin ningun otro cambio dentro: ejecutar los dos .js y los dos .py y
verificar con qa-deck y preview-pptx.

Co-Authored-By: Claude Fable 5 <noreply@anthropic.com>
</commit_message>
<xml_diff>
--- a/docs/common/marketing/presentations/DRP-resumen.pptx
+++ b/docs/common/marketing/presentations/DRP-resumen.pptx
@@ -797,7 +797,7 @@
           <a:p>
             <a:r>
               <a:rPr lang="en-US" dirty="0"/>
-              <a:t>Portada. Resumen del README.md de DRP (estado 2026-08-19): Fases 0, 1 y 2 cerradas. El core completo y los cuatro módulos de prioridad alta, activables hogar por hogar.</a:t>
+              <a:t>Portada. Resumen del README.md de DRP (estado 2026-08-20): Fases 0, 1 y 2 y el cierre de huecos cerrados. El core completo y los cuatro módulos de prioridad alta, activables hogar por hogar.</a:t>
             </a:r>
             <a:endParaRPr lang="en-US" dirty="0"/>
           </a:p>
@@ -1589,7 +1589,7 @@
           <a:p>
             <a:r>
               <a:rPr lang="en-US" dirty="0"/>
-              <a:t>README §8: roadmap y estado. Fase 0 cerrada el 2026-08-07, Fase 1 el 2026-08-17 y Fase 2 el 2026-08-19. El detalle de cada una vive en su propio roadmap, en docs/common/product/.</a:t>
+              <a:t>README §8: roadmap y estado. Fase 0 cerrada el 2026-08-07, Fase 1 el 2026-08-17, Fase 2 el 2026-08-19 y el cierre de huecos —que no es una fase y por eso no lleva tarjeta numerada— el 2026-08-20. El detalle de cada bloque vive en su propio roadmap, en docs/common/product/.</a:t>
             </a:r>
             <a:endParaRPr lang="en-US" dirty="0"/>
           </a:p>
@@ -1677,7 +1677,7 @@
           <a:p>
             <a:r>
               <a:rPr lang="en-US" dirty="0"/>
-              <a:t>README §8, §9 y §11: cierre de la Fase 2 y lo que queda para la Fase 3, que todavía no está planificada.</a:t>
+              <a:t>README §8, §9 y §11: cierre de la Fase 2 y del cierre de huecos, y lo que queda para la Fase 3, que todavía no está planificada.</a:t>
             </a:r>
             <a:endParaRPr lang="en-US" dirty="0"/>
           </a:p>
@@ -2883,7 +2883,7 @@
         <p:spPr>
           <a:xfrm>
             <a:off x="868680" y="4526280"/>
-            <a:ext cx="1993392" cy="384048"/>
+            <a:ext cx="2862072" cy="384048"/>
           </a:xfrm>
           <a:prstGeom prst="roundRect">
             <a:avLst>
@@ -2910,7 +2910,7 @@
         <p:spPr>
           <a:xfrm>
             <a:off x="868680" y="4526280"/>
-            <a:ext cx="1993392" cy="384048"/>
+            <a:ext cx="2862072" cy="384048"/>
           </a:xfrm>
           <a:prstGeom prst="rect">
             <a:avLst/>
@@ -2934,7 +2934,7 @@
                 <a:ea typeface="Calibri" pitchFamily="34" charset="-122"/>
                 <a:cs typeface="Calibri" pitchFamily="34" charset="-120"/>
               </a:rPr>
-              <a:t>Fases 1 y 2 cerradas</a:t>
+              <a:t>Fases 1 y 2 + cierre de huecos</a:t>
             </a:r>
             <a:endParaRPr lang="en-US" sz="1150" dirty="0"/>
           </a:p>
@@ -2948,7 +2948,7 @@
         </p:nvSpPr>
         <p:spPr>
           <a:xfrm>
-            <a:off x="3026664" y="4526280"/>
+            <a:off x="3895344" y="4526280"/>
             <a:ext cx="1645920" cy="384048"/>
           </a:xfrm>
           <a:prstGeom prst="roundRect">
@@ -2975,7 +2975,7 @@
         </p:nvSpPr>
         <p:spPr>
           <a:xfrm>
-            <a:off x="3026664" y="4526280"/>
+            <a:off x="3895344" y="4526280"/>
             <a:ext cx="1645920" cy="384048"/>
           </a:xfrm>
           <a:prstGeom prst="rect">
@@ -3014,7 +3014,7 @@
         </p:nvSpPr>
         <p:spPr>
           <a:xfrm>
-            <a:off x="4837176" y="4526280"/>
+            <a:off x="5705856" y="4526280"/>
             <a:ext cx="1124712" cy="384048"/>
           </a:xfrm>
           <a:prstGeom prst="roundRect">
@@ -3041,7 +3041,7 @@
         </p:nvSpPr>
         <p:spPr>
           <a:xfrm>
-            <a:off x="4837176" y="4526280"/>
+            <a:off x="5705856" y="4526280"/>
             <a:ext cx="1124712" cy="384048"/>
           </a:xfrm>
           <a:prstGeom prst="rect">
@@ -3066,7 +3066,7 @@
                 <a:ea typeface="Calibri" pitchFamily="34" charset="-122"/>
                 <a:cs typeface="Calibri" pitchFamily="34" charset="-120"/>
               </a:rPr>
-              <a:t>2026-08-19</a:t>
+              <a:t>2026-08-20</a:t>
             </a:r>
             <a:endParaRPr lang="en-US" sz="1150" dirty="0"/>
           </a:p>
@@ -12698,7 +12698,7 @@
                 <a:ea typeface="Calibri" pitchFamily="34" charset="-122"/>
                 <a:cs typeface="Calibri" pitchFamily="34" charset="-120"/>
               </a:rPr>
-              <a:t>openapi.yaml, 98 operaciones, fuente de verdad</a:t>
+              <a:t>openapi.yaml, 106 operaciones, fuente de verdad</a:t>
             </a:r>
             <a:endParaRPr lang="en-US" sz="1100" dirty="0"/>
           </a:p>
@@ -15066,8 +15066,8 @@
         </p:nvSpPr>
         <p:spPr>
           <a:xfrm>
-            <a:off x="548640" y="5166360"/>
-            <a:ext cx="11094415" cy="502920"/>
+            <a:off x="548640" y="5047488"/>
+            <a:ext cx="11094415" cy="457200"/>
           </a:xfrm>
           <a:prstGeom prst="rect">
             <a:avLst/>
@@ -15081,12 +15081,54 @@
           <a:p>
             <a:pPr indent="0" marL="0">
               <a:lnSpc>
-                <a:spcPts val="1900"/>
+                <a:spcPts val="1700"/>
               </a:lnSpc>
               <a:buNone/>
             </a:pPr>
             <a:r>
-              <a:rPr lang="en-US" sz="1300" i="1" dirty="0">
+              <a:rPr lang="en-US" sz="1200" dirty="0">
+                <a:solidFill>
+                  <a:srgbClr val="5F706E"/>
+                </a:solidFill>
+                <a:latin typeface="Calibri" pitchFamily="34" charset="0"/>
+                <a:ea typeface="Calibri" pitchFamily="34" charset="-122"/>
+                <a:cs typeface="Calibri" pitchFamily="34" charset="-120"/>
+              </a:rPr>
+              <a:t>Entre la Fase 2 y la 3, un bloque sin número completado el 2026-08-20 — el cierre de huecos: baja de hogar y de cuenta, Transactional Outbox, conversión de HEIC, los cuatro atributos propuestos y el «hoy» del hogar.</a:t>
+            </a:r>
+            <a:endParaRPr lang="en-US" sz="1200" dirty="0"/>
+          </a:p>
+        </p:txBody>
+      </p:sp>
+      <p:sp>
+        <p:nvSpPr>
+          <p:cNvPr id="37" name="Text 35"/>
+          <p:cNvSpPr/>
+          <p:nvPr/>
+        </p:nvSpPr>
+        <p:spPr>
+          <a:xfrm>
+            <a:off x="548640" y="5577840"/>
+            <a:ext cx="11094415" cy="457200"/>
+          </a:xfrm>
+          <a:prstGeom prst="rect">
+            <a:avLst/>
+          </a:prstGeom>
+          <a:noFill/>
+          <a:ln/>
+        </p:spPr>
+        <p:txBody>
+          <a:bodyPr wrap="square" lIns="0" tIns="0" rIns="0" bIns="0" rtlCol="0" anchor="t"/>
+          <a:lstStyle/>
+          <a:p>
+            <a:pPr indent="0" marL="0">
+              <a:lnSpc>
+                <a:spcPts val="1700"/>
+              </a:lnSpc>
+              <a:buNone/>
+            </a:pPr>
+            <a:r>
+              <a:rPr lang="en-US" sz="1200" i="1" dirty="0">
                 <a:solidFill>
                   <a:srgbClr val="2E7B72"/>
                 </a:solidFill>
@@ -15094,15 +15136,15 @@
                 <a:ea typeface="Calibri" pitchFamily="34" charset="-122"/>
                 <a:cs typeface="Calibri" pitchFamily="34" charset="-120"/>
               </a:rPr>
-              <a:t>Criterio de validación (ADR-001), cumplido en las dos fases entregadas: un recorrido vertical que atraviesa frontend, API autenticada, aplicación, dominio y PostgreSQL. Hoy son siete, en un navegador de verdad.</a:t>
-            </a:r>
-            <a:endParaRPr lang="en-US" sz="1300" dirty="0"/>
-          </a:p>
-        </p:txBody>
-      </p:sp>
-      <p:sp>
-        <p:nvSpPr>
-          <p:cNvPr id="37" name="Text 35"/>
+              <a:t>Criterio de validación (ADR-001), cumplido en todo lo entregado: un recorrido vertical que atraviesa frontend, API autenticada, aplicación, dominio y PostgreSQL. Hoy son diez, en un navegador de verdad.</a:t>
+            </a:r>
+            <a:endParaRPr lang="en-US" sz="1200" dirty="0"/>
+          </a:p>
+        </p:txBody>
+      </p:sp>
+      <p:sp>
+        <p:nvSpPr>
+          <p:cNvPr id="38" name="Text 36"/>
           <p:cNvSpPr/>
           <p:nvPr/>
         </p:nvSpPr>
@@ -15141,7 +15183,7 @@
       </p:sp>
       <p:sp>
         <p:nvSpPr>
-          <p:cNvPr id="38" name="Text 36"/>
+          <p:cNvPr id="39" name="Text 37"/>
           <p:cNvSpPr/>
           <p:nvPr/>
         </p:nvSpPr>
@@ -15282,7 +15324,7 @@
                 <a:ea typeface="Cambria" pitchFamily="34" charset="-122"/>
                 <a:cs typeface="Cambria" pitchFamily="34" charset="-120"/>
               </a:rPr>
-              <a:t>El core y los cuatro primeros módulos, entregados</a:t>
+              <a:t>El core, cuatro módulos y el cierre de huecos, entregados</a:t>
             </a:r>
             <a:endParaRPr lang="en-US" sz="3200" dirty="0"/>
           </a:p>
@@ -15901,7 +15943,7 @@
                 <a:ea typeface="Calibri" pitchFamily="34" charset="-122"/>
                 <a:cs typeface="Calibri" pitchFamily="34" charset="-120"/>
               </a:rPr>
-              <a:t>El core completo y cuatro módulos, sobre activación por hogar y avisos programados. 98 operaciones en el contrato, 28 tablas con Row-Level Security y siete recorridos verticales.</a:t>
+              <a:t>El core completo, cuatro módulos y el cierre de huecos, sobre activación por hogar y avisos programados. 106 operaciones en el contrato, 31 tablas con Row-Level Security y diez recorridos verticales.</a:t>
             </a:r>
             <a:endParaRPr lang="en-US" sz="1250" dirty="0"/>
           </a:p>
@@ -16048,7 +16090,7 @@
                 <a:ea typeface="Calibri" pitchFamily="34" charset="-122"/>
                 <a:cs typeface="Calibri" pitchFamily="34" charset="-120"/>
               </a:rPr>
-              <a:t>Fuente: README.md · documento vivo, última actualización 2026-08-19</a:t>
+              <a:t>Fuente: README.md · documento vivo, última actualización 2026-08-20</a:t>
             </a:r>
             <a:endParaRPr lang="en-US" sz="1100" dirty="0"/>
           </a:p>

</xml_diff>